<commit_message>
Presentation done so far changed to timeline
</commit_message>
<xml_diff>
--- a/Presentation/SiteSafeAiPresentation.pptx
+++ b/Presentation/SiteSafeAiPresentation.pptx
@@ -3489,10 +3489,10 @@
         <a:lstStyle/>
         <a:p>
           <a:r>
-            <a:rPr lang="en-GB"/>
-            <a:t>Reviewed Technology Documentation</a:t>
+            <a:rPr lang="en-GB" dirty="0"/>
+            <a:t>Functional Specifications</a:t>
           </a:r>
-          <a:endParaRPr lang="en-US"/>
+          <a:endParaRPr lang="en-US" dirty="0"/>
         </a:p>
       </dgm:t>
     </dgm:pt>
@@ -3526,10 +3526,10 @@
         <a:lstStyle/>
         <a:p>
           <a:r>
-            <a:rPr lang="en-GB"/>
-            <a:t>Completed Tutorials</a:t>
+            <a:rPr lang="en-GB" dirty="0"/>
+            <a:t>Poster, Presentation</a:t>
           </a:r>
-          <a:endParaRPr lang="en-US"/>
+          <a:endParaRPr lang="en-US" dirty="0"/>
         </a:p>
       </dgm:t>
     </dgm:pt>
@@ -3563,10 +3563,10 @@
         <a:lstStyle/>
         <a:p>
           <a:r>
-            <a:rPr lang="en-GB"/>
-            <a:t>Created Logo</a:t>
+            <a:rPr lang="en-GB" dirty="0"/>
+            <a:t>Model Trained on 500 images</a:t>
           </a:r>
-          <a:endParaRPr lang="en-US"/>
+          <a:endParaRPr lang="en-US" dirty="0"/>
         </a:p>
       </dgm:t>
     </dgm:pt>
@@ -3600,10 +3600,10 @@
         <a:lstStyle/>
         <a:p>
           <a:r>
-            <a:rPr lang="en-GB"/>
-            <a:t>Detailed Project Specifications</a:t>
+            <a:rPr lang="en-GB" dirty="0"/>
+            <a:t>Model Tested</a:t>
           </a:r>
-          <a:endParaRPr lang="en-US"/>
+          <a:endParaRPr lang="en-US" dirty="0"/>
         </a:p>
       </dgm:t>
     </dgm:pt>
@@ -3637,10 +3637,10 @@
         <a:lstStyle/>
         <a:p>
           <a:r>
-            <a:rPr lang="en-GB"/>
-            <a:t>Developed Project Poster</a:t>
+            <a:rPr lang="en-GB" dirty="0"/>
+            <a:t>Front-End Page Layout</a:t>
           </a:r>
-          <a:endParaRPr lang="en-US"/>
+          <a:endParaRPr lang="en-US" dirty="0"/>
         </a:p>
       </dgm:t>
     </dgm:pt>
@@ -5663,7 +5663,7 @@
         </a:bodyPr>
         <a:lstStyle/>
         <a:p>
-          <a:pPr marL="0" lvl="0" indent="0" algn="ctr" defTabSz="1333500">
+          <a:pPr marL="0" lvl="0" indent="0" algn="ctr" defTabSz="1466850">
             <a:lnSpc>
               <a:spcPct val="90000"/>
             </a:lnSpc>
@@ -5676,10 +5676,10 @@
             <a:buNone/>
           </a:pPr>
           <a:r>
-            <a:rPr lang="en-GB" sz="3000" kern="1200" dirty="0"/>
+            <a:rPr lang="en-GB" sz="3300" kern="1200" dirty="0"/>
             <a:t>Finalised Technologies</a:t>
           </a:r>
-          <a:endParaRPr lang="en-US" sz="3000" kern="1200" dirty="0"/>
+          <a:endParaRPr lang="en-US" sz="3300" kern="1200" dirty="0"/>
         </a:p>
       </dsp:txBody>
       <dsp:txXfrm>
@@ -5823,7 +5823,7 @@
         </a:bodyPr>
         <a:lstStyle/>
         <a:p>
-          <a:pPr marL="0" lvl="0" indent="0" algn="ctr" defTabSz="1333500">
+          <a:pPr marL="0" lvl="0" indent="0" algn="ctr" defTabSz="1466850">
             <a:lnSpc>
               <a:spcPct val="90000"/>
             </a:lnSpc>
@@ -5836,10 +5836,10 @@
             <a:buNone/>
           </a:pPr>
           <a:r>
-            <a:rPr lang="en-GB" sz="3000" kern="1200"/>
-            <a:t>Reviewed Technology Documentation</a:t>
+            <a:rPr lang="en-GB" sz="3300" kern="1200" dirty="0"/>
+            <a:t>Functional Specifications</a:t>
           </a:r>
-          <a:endParaRPr lang="en-US" sz="3000" kern="1200"/>
+          <a:endParaRPr lang="en-US" sz="3300" kern="1200" dirty="0"/>
         </a:p>
       </dsp:txBody>
       <dsp:txXfrm>
@@ -5989,7 +5989,7 @@
         </a:bodyPr>
         <a:lstStyle/>
         <a:p>
-          <a:pPr marL="0" lvl="0" indent="0" algn="ctr" defTabSz="1333500">
+          <a:pPr marL="0" lvl="0" indent="0" algn="ctr" defTabSz="1466850">
             <a:lnSpc>
               <a:spcPct val="90000"/>
             </a:lnSpc>
@@ -6002,10 +6002,10 @@
             <a:buNone/>
           </a:pPr>
           <a:r>
-            <a:rPr lang="en-GB" sz="3000" kern="1200"/>
-            <a:t>Completed Tutorials</a:t>
+            <a:rPr lang="en-GB" sz="3300" kern="1200" dirty="0"/>
+            <a:t>Poster, Presentation</a:t>
           </a:r>
-          <a:endParaRPr lang="en-US" sz="3000" kern="1200"/>
+          <a:endParaRPr lang="en-US" sz="3300" kern="1200" dirty="0"/>
         </a:p>
       </dsp:txBody>
       <dsp:txXfrm>
@@ -6149,7 +6149,7 @@
         </a:bodyPr>
         <a:lstStyle/>
         <a:p>
-          <a:pPr marL="0" lvl="0" indent="0" algn="ctr" defTabSz="1333500">
+          <a:pPr marL="0" lvl="0" indent="0" algn="ctr" defTabSz="1466850">
             <a:lnSpc>
               <a:spcPct val="90000"/>
             </a:lnSpc>
@@ -6162,10 +6162,10 @@
             <a:buNone/>
           </a:pPr>
           <a:r>
-            <a:rPr lang="en-GB" sz="3000" kern="1200"/>
-            <a:t>Created Logo</a:t>
+            <a:rPr lang="en-GB" sz="3300" kern="1200" dirty="0"/>
+            <a:t>Model Trained on 500 images</a:t>
           </a:r>
-          <a:endParaRPr lang="en-US" sz="3000" kern="1200"/>
+          <a:endParaRPr lang="en-US" sz="3300" kern="1200" dirty="0"/>
         </a:p>
       </dsp:txBody>
       <dsp:txXfrm>
@@ -6309,7 +6309,7 @@
         </a:bodyPr>
         <a:lstStyle/>
         <a:p>
-          <a:pPr marL="0" lvl="0" indent="0" algn="ctr" defTabSz="1333500">
+          <a:pPr marL="0" lvl="0" indent="0" algn="ctr" defTabSz="1466850">
             <a:lnSpc>
               <a:spcPct val="90000"/>
             </a:lnSpc>
@@ -6322,10 +6322,10 @@
             <a:buNone/>
           </a:pPr>
           <a:r>
-            <a:rPr lang="en-GB" sz="3000" kern="1200"/>
-            <a:t>Detailed Project Specifications</a:t>
+            <a:rPr lang="en-GB" sz="3300" kern="1200" dirty="0"/>
+            <a:t>Model Tested</a:t>
           </a:r>
-          <a:endParaRPr lang="en-US" sz="3000" kern="1200"/>
+          <a:endParaRPr lang="en-US" sz="3300" kern="1200" dirty="0"/>
         </a:p>
       </dsp:txBody>
       <dsp:txXfrm>
@@ -6388,7 +6388,7 @@
         </a:bodyPr>
         <a:lstStyle/>
         <a:p>
-          <a:pPr marL="0" lvl="0" indent="0" algn="ctr" defTabSz="1333500">
+          <a:pPr marL="0" lvl="0" indent="0" algn="ctr" defTabSz="1466850">
             <a:lnSpc>
               <a:spcPct val="90000"/>
             </a:lnSpc>
@@ -6401,10 +6401,10 @@
             <a:buNone/>
           </a:pPr>
           <a:r>
-            <a:rPr lang="en-GB" sz="3000" kern="1200"/>
-            <a:t>Developed Project Poster</a:t>
+            <a:rPr lang="en-GB" sz="3300" kern="1200" dirty="0"/>
+            <a:t>Front-End Page Layout</a:t>
           </a:r>
-          <a:endParaRPr lang="en-US" sz="3000" kern="1200"/>
+          <a:endParaRPr lang="en-US" sz="3300" kern="1200" dirty="0"/>
         </a:p>
       </dsp:txBody>
       <dsp:txXfrm>
@@ -11184,7 +11184,7 @@
           <a:p>
             <a:fld id="{74FCF980-36E5-46BF-A02A-756B7FE0A693}" type="datetimeFigureOut">
               <a:rPr lang="en-GB" smtClean="0"/>
-              <a:t>11/11/2024</a:t>
+              <a:t>30/11/2024</a:t>
             </a:fld>
             <a:endParaRPr lang="en-GB"/>
           </a:p>
@@ -11601,7 +11601,7 @@
           <a:p>
             <a:fld id="{7E55B3EA-B30C-4CE3-B538-BC7F603EE92A}" type="datetime1">
               <a:rPr lang="en-GB" smtClean="0"/>
-              <a:t>11/11/2024</a:t>
+              <a:t>30/11/2024</a:t>
             </a:fld>
             <a:endParaRPr lang="en-GB"/>
           </a:p>
@@ -11801,7 +11801,7 @@
           <a:p>
             <a:fld id="{908DF4FF-43EB-43ED-BF8E-EF1421EE1B33}" type="datetime1">
               <a:rPr lang="en-GB" smtClean="0"/>
-              <a:t>11/11/2024</a:t>
+              <a:t>30/11/2024</a:t>
             </a:fld>
             <a:endParaRPr lang="en-GB"/>
           </a:p>
@@ -12011,7 +12011,7 @@
           <a:p>
             <a:fld id="{F5FB5ABF-7BF5-4383-BD15-C04E1EF89981}" type="datetime1">
               <a:rPr lang="en-GB" smtClean="0"/>
-              <a:t>11/11/2024</a:t>
+              <a:t>30/11/2024</a:t>
             </a:fld>
             <a:endParaRPr lang="en-GB"/>
           </a:p>
@@ -12211,7 +12211,7 @@
           <a:p>
             <a:fld id="{3249EB88-2E63-470B-B5AE-ED8F04DEB571}" type="datetime1">
               <a:rPr lang="en-GB" smtClean="0"/>
-              <a:t>11/11/2024</a:t>
+              <a:t>30/11/2024</a:t>
             </a:fld>
             <a:endParaRPr lang="en-GB" dirty="0"/>
           </a:p>
@@ -12508,7 +12508,7 @@
           <a:p>
             <a:fld id="{8A25558C-F5C9-425F-A937-DAD336474D19}" type="datetime1">
               <a:rPr lang="en-GB" smtClean="0"/>
-              <a:t>11/11/2024</a:t>
+              <a:t>30/11/2024</a:t>
             </a:fld>
             <a:endParaRPr lang="en-GB"/>
           </a:p>
@@ -12776,7 +12776,7 @@
           <a:p>
             <a:fld id="{78F23361-B348-4CBC-9D98-FFEC573232E9}" type="datetime1">
               <a:rPr lang="en-GB" smtClean="0"/>
-              <a:t>11/11/2024</a:t>
+              <a:t>30/11/2024</a:t>
             </a:fld>
             <a:endParaRPr lang="en-GB"/>
           </a:p>
@@ -13191,7 +13191,7 @@
           <a:p>
             <a:fld id="{209E1356-F7A0-4DDA-9B79-8677F0203A36}" type="datetime1">
               <a:rPr lang="en-GB" smtClean="0"/>
-              <a:t>11/11/2024</a:t>
+              <a:t>30/11/2024</a:t>
             </a:fld>
             <a:endParaRPr lang="en-GB"/>
           </a:p>
@@ -13333,7 +13333,7 @@
           <a:p>
             <a:fld id="{7B0BD8A4-DB30-4644-BD53-95B03F580EBF}" type="datetime1">
               <a:rPr lang="en-GB" smtClean="0"/>
-              <a:t>11/11/2024</a:t>
+              <a:t>30/11/2024</a:t>
             </a:fld>
             <a:endParaRPr lang="en-GB"/>
           </a:p>
@@ -13446,7 +13446,7 @@
           <a:p>
             <a:fld id="{EBE70D1A-1D8E-4DCC-9397-026B2065BFC1}" type="datetime1">
               <a:rPr lang="en-GB" smtClean="0"/>
-              <a:t>11/11/2024</a:t>
+              <a:t>30/11/2024</a:t>
             </a:fld>
             <a:endParaRPr lang="en-GB"/>
           </a:p>
@@ -13759,7 +13759,7 @@
           <a:p>
             <a:fld id="{1D27C71C-4D63-45B1-B210-A6E88395339E}" type="datetime1">
               <a:rPr lang="en-GB" smtClean="0"/>
-              <a:t>11/11/2024</a:t>
+              <a:t>30/11/2024</a:t>
             </a:fld>
             <a:endParaRPr lang="en-GB"/>
           </a:p>
@@ -14048,7 +14048,7 @@
           <a:p>
             <a:fld id="{CE4A0315-D938-4806-831E-5BEF87E79DEC}" type="datetime1">
               <a:rPr lang="en-GB" smtClean="0"/>
-              <a:t>11/11/2024</a:t>
+              <a:t>30/11/2024</a:t>
             </a:fld>
             <a:endParaRPr lang="en-GB"/>
           </a:p>
@@ -14291,7 +14291,7 @@
           <a:p>
             <a:fld id="{EDF9EF3A-9B5C-4F8E-BE21-1A9759F13C31}" type="datetime1">
               <a:rPr lang="en-GB" smtClean="0"/>
-              <a:t>11/11/2024</a:t>
+              <a:t>30/11/2024</a:t>
             </a:fld>
             <a:endParaRPr lang="en-GB"/>
           </a:p>
@@ -26407,7 +26407,7 @@
             <p:ph idx="1"/>
             <p:extLst>
               <p:ext uri="{D42A27DB-BD31-4B8C-83A1-F6EECF244321}">
-                <p14:modId xmlns:p14="http://schemas.microsoft.com/office/powerpoint/2010/main" val="1814779552"/>
+                <p14:modId xmlns:p14="http://schemas.microsoft.com/office/powerpoint/2010/main" val="484401191"/>
               </p:ext>
             </p:extLst>
           </p:nvPr>

</xml_diff>

<commit_message>
Text size increase technologies iteration 1
</commit_message>
<xml_diff>
--- a/Presentation/SiteSafeAiPresentation.pptx
+++ b/Presentation/SiteSafeAiPresentation.pptx
@@ -2561,7 +2561,7 @@
       </dgm:t>
     </dgm:pt>
     <dgm:pt modelId="{694B7AF4-3A8B-4ADF-926E-D04343A67A5B}">
-      <dgm:prSet/>
+      <dgm:prSet custT="1"/>
       <dgm:spPr/>
       <dgm:t>
         <a:bodyPr/>
@@ -2573,10 +2573,10 @@
             </a:lnSpc>
           </a:pPr>
           <a:r>
-            <a:rPr lang="en-GB" dirty="0"/>
+            <a:rPr lang="en-GB" sz="1800" dirty="0"/>
             <a:t>Python - Main Programming Language</a:t>
           </a:r>
-          <a:endParaRPr lang="en-US" dirty="0"/>
+          <a:endParaRPr lang="en-US" sz="1800" dirty="0"/>
         </a:p>
       </dgm:t>
     </dgm:pt>
@@ -2608,7 +2608,7 @@
       </dgm:t>
     </dgm:pt>
     <dgm:pt modelId="{FAE58B5E-C93F-41D0-A6F6-D1E16200C15F}">
-      <dgm:prSet/>
+      <dgm:prSet custT="1"/>
       <dgm:spPr/>
       <dgm:t>
         <a:bodyPr/>
@@ -2620,10 +2620,10 @@
             </a:lnSpc>
           </a:pPr>
           <a:r>
-            <a:rPr lang="en-GB" dirty="0"/>
+            <a:rPr lang="en-GB" sz="1800" dirty="0"/>
             <a:t>YOLO - Object Detection  </a:t>
           </a:r>
-          <a:endParaRPr lang="en-US" dirty="0"/>
+          <a:endParaRPr lang="en-US" sz="1800" dirty="0"/>
         </a:p>
       </dgm:t>
     </dgm:pt>
@@ -2655,7 +2655,7 @@
       </dgm:t>
     </dgm:pt>
     <dgm:pt modelId="{A936FE28-DE30-4F99-9D61-A0E9F5DEDAEB}">
-      <dgm:prSet/>
+      <dgm:prSet custT="1"/>
       <dgm:spPr/>
       <dgm:t>
         <a:bodyPr/>
@@ -2667,10 +2667,14 @@
             </a:lnSpc>
           </a:pPr>
           <a:r>
-            <a:rPr lang="en-GB"/>
-            <a:t>Ultralytics - Framework</a:t>
+            <a:rPr lang="en-GB" sz="1800" dirty="0" err="1"/>
+            <a:t>Ultralytics</a:t>
           </a:r>
-          <a:endParaRPr lang="en-US"/>
+          <a:r>
+            <a:rPr lang="en-GB" sz="1800" dirty="0"/>
+            <a:t> - Framework</a:t>
+          </a:r>
+          <a:endParaRPr lang="en-US" sz="1800" dirty="0"/>
         </a:p>
       </dgm:t>
     </dgm:pt>
@@ -2702,7 +2706,7 @@
       </dgm:t>
     </dgm:pt>
     <dgm:pt modelId="{05172726-9EC8-4DAB-9C24-AF72B6B26FE5}">
-      <dgm:prSet/>
+      <dgm:prSet custT="1"/>
       <dgm:spPr/>
       <dgm:t>
         <a:bodyPr/>
@@ -2714,10 +2718,10 @@
             </a:lnSpc>
           </a:pPr>
           <a:r>
-            <a:rPr lang="en-GB" dirty="0"/>
+            <a:rPr lang="en-GB" sz="1800" dirty="0"/>
             <a:t>OpenCV – Computer Vision Library</a:t>
           </a:r>
-          <a:endParaRPr lang="en-US" dirty="0"/>
+          <a:endParaRPr lang="en-US" sz="1800" dirty="0"/>
         </a:p>
       </dgm:t>
     </dgm:pt>
@@ -2749,7 +2753,7 @@
       </dgm:t>
     </dgm:pt>
     <dgm:pt modelId="{472CDD00-1D69-4A6B-8AC4-8A36F0E79CA1}">
-      <dgm:prSet/>
+      <dgm:prSet custT="1"/>
       <dgm:spPr/>
       <dgm:t>
         <a:bodyPr/>
@@ -2761,10 +2765,10 @@
             </a:lnSpc>
           </a:pPr>
           <a:r>
-            <a:rPr lang="en-GB"/>
+            <a:rPr lang="en-GB" sz="1800" dirty="0"/>
             <a:t>Flask – Web Framework</a:t>
           </a:r>
-          <a:endParaRPr lang="en-US"/>
+          <a:endParaRPr lang="en-US" sz="1800" dirty="0"/>
         </a:p>
       </dgm:t>
     </dgm:pt>
@@ -2796,7 +2800,7 @@
       </dgm:t>
     </dgm:pt>
     <dgm:pt modelId="{6153FF18-8BD2-45BB-854A-CD8632CDC26A}">
-      <dgm:prSet/>
+      <dgm:prSet custT="1"/>
       <dgm:spPr/>
       <dgm:t>
         <a:bodyPr/>
@@ -2808,10 +2812,10 @@
             </a:lnSpc>
           </a:pPr>
           <a:r>
-            <a:rPr lang="en-GB"/>
+            <a:rPr lang="en-GB" sz="1800" dirty="0"/>
             <a:t>React – Front End</a:t>
           </a:r>
-          <a:endParaRPr lang="en-US"/>
+          <a:endParaRPr lang="en-US" sz="1800" dirty="0"/>
         </a:p>
       </dgm:t>
     </dgm:pt>
@@ -2843,7 +2847,7 @@
       </dgm:t>
     </dgm:pt>
     <dgm:pt modelId="{D4B3BAF0-1DFF-452A-8E9F-7F6DAEDD5259}">
-      <dgm:prSet/>
+      <dgm:prSet custT="1"/>
       <dgm:spPr/>
       <dgm:t>
         <a:bodyPr/>
@@ -2855,10 +2859,10 @@
             </a:lnSpc>
           </a:pPr>
           <a:r>
-            <a:rPr lang="en-GB"/>
+            <a:rPr lang="en-GB" sz="1800" dirty="0"/>
             <a:t>SMTP – Email Service</a:t>
           </a:r>
-          <a:endParaRPr lang="en-US"/>
+          <a:endParaRPr lang="en-US" sz="1800" dirty="0"/>
         </a:p>
       </dgm:t>
     </dgm:pt>
@@ -2890,7 +2894,7 @@
       </dgm:t>
     </dgm:pt>
     <dgm:pt modelId="{E3A74F75-AC17-48AD-A734-885D21E05F60}">
-      <dgm:prSet/>
+      <dgm:prSet custT="1"/>
       <dgm:spPr/>
       <dgm:t>
         <a:bodyPr/>
@@ -2902,10 +2906,10 @@
             </a:lnSpc>
           </a:pPr>
           <a:r>
-            <a:rPr lang="en-GB"/>
+            <a:rPr lang="en-GB" sz="1800" dirty="0"/>
             <a:t>MySQL - Database</a:t>
           </a:r>
-          <a:endParaRPr lang="en-US"/>
+          <a:endParaRPr lang="en-US" sz="1800" dirty="0"/>
         </a:p>
       </dgm:t>
     </dgm:pt>
@@ -2987,7 +2991,7 @@
       <dgm:spPr/>
     </dgm:pt>
     <dgm:pt modelId="{78D769C6-C2A1-4934-8341-175D00ECACE4}" type="pres">
-      <dgm:prSet presAssocID="{694B7AF4-3A8B-4ADF-926E-D04343A67A5B}" presName="textRect" presStyleLbl="revTx" presStyleIdx="0" presStyleCnt="8">
+      <dgm:prSet presAssocID="{694B7AF4-3A8B-4ADF-926E-D04343A67A5B}" presName="textRect" presStyleLbl="revTx" presStyleIdx="0" presStyleCnt="8" custScaleX="102100">
         <dgm:presLayoutVars>
           <dgm:chMax val="1"/>
           <dgm:chPref val="1"/>
@@ -4258,7 +4262,7 @@
       </dsp:nvSpPr>
       <dsp:spPr>
         <a:xfrm>
-          <a:off x="921098" y="459"/>
+          <a:off x="914308" y="459"/>
           <a:ext cx="548690" cy="548690"/>
         </a:xfrm>
         <a:prstGeom prst="ellipse">
@@ -4298,7 +4302,7 @@
       </dsp:nvSpPr>
       <dsp:spPr>
         <a:xfrm>
-          <a:off x="1036323" y="115684"/>
+          <a:off x="1029533" y="115684"/>
           <a:ext cx="318240" cy="318240"/>
         </a:xfrm>
         <a:prstGeom prst="rect">
@@ -4355,8 +4359,8 @@
       </dsp:nvSpPr>
       <dsp:spPr>
         <a:xfrm>
-          <a:off x="1587365" y="459"/>
-          <a:ext cx="1293342" cy="548690"/>
+          <a:off x="1566995" y="459"/>
+          <a:ext cx="1320502" cy="548690"/>
         </a:xfrm>
         <a:prstGeom prst="rect">
           <a:avLst/>
@@ -4385,7 +4389,7 @@
         </a:bodyPr>
         <a:lstStyle/>
         <a:p>
-          <a:pPr marL="0" lvl="0" indent="0" algn="l" defTabSz="488950">
+          <a:pPr marL="0" lvl="0" indent="0" algn="l" defTabSz="800100">
             <a:lnSpc>
               <a:spcPct val="100000"/>
             </a:lnSpc>
@@ -4398,15 +4402,15 @@
             <a:buNone/>
           </a:pPr>
           <a:r>
-            <a:rPr lang="en-GB" sz="1100" kern="1200" dirty="0"/>
+            <a:rPr lang="en-GB" sz="1800" kern="1200" dirty="0"/>
             <a:t>Python - Main Programming Language</a:t>
           </a:r>
-          <a:endParaRPr lang="en-US" sz="1100" kern="1200" dirty="0"/>
+          <a:endParaRPr lang="en-US" sz="1800" kern="1200" dirty="0"/>
         </a:p>
       </dsp:txBody>
       <dsp:txXfrm>
-        <a:off x="1587365" y="459"/>
-        <a:ext cx="1293342" cy="548690"/>
+        <a:off x="1566995" y="459"/>
+        <a:ext cx="1320502" cy="548690"/>
       </dsp:txXfrm>
     </dsp:sp>
     <dsp:sp modelId="{6429BE27-F80E-40E8-AD6E-BCF5F22ACF2F}">
@@ -4416,7 +4420,7 @@
       </dsp:nvSpPr>
       <dsp:spPr>
         <a:xfrm>
-          <a:off x="3106062" y="459"/>
+          <a:off x="3112852" y="459"/>
           <a:ext cx="548690" cy="548690"/>
         </a:xfrm>
         <a:prstGeom prst="ellipse">
@@ -4456,7 +4460,7 @@
       </dsp:nvSpPr>
       <dsp:spPr>
         <a:xfrm>
-          <a:off x="3221287" y="115684"/>
+          <a:off x="3228077" y="115684"/>
           <a:ext cx="318240" cy="318240"/>
         </a:xfrm>
         <a:prstGeom prst="rect">
@@ -4513,7 +4517,7 @@
       </dsp:nvSpPr>
       <dsp:spPr>
         <a:xfrm>
-          <a:off x="3772329" y="459"/>
+          <a:off x="3779119" y="459"/>
           <a:ext cx="1293342" cy="548690"/>
         </a:xfrm>
         <a:prstGeom prst="rect">
@@ -4543,7 +4547,7 @@
         </a:bodyPr>
         <a:lstStyle/>
         <a:p>
-          <a:pPr marL="0" lvl="0" indent="0" algn="l" defTabSz="488950">
+          <a:pPr marL="0" lvl="0" indent="0" algn="l" defTabSz="800100">
             <a:lnSpc>
               <a:spcPct val="100000"/>
             </a:lnSpc>
@@ -4556,14 +4560,14 @@
             <a:buNone/>
           </a:pPr>
           <a:r>
-            <a:rPr lang="en-GB" sz="1100" kern="1200" dirty="0"/>
+            <a:rPr lang="en-GB" sz="1800" kern="1200" dirty="0"/>
             <a:t>YOLO - Object Detection  </a:t>
           </a:r>
-          <a:endParaRPr lang="en-US" sz="1100" kern="1200" dirty="0"/>
+          <a:endParaRPr lang="en-US" sz="1800" kern="1200" dirty="0"/>
         </a:p>
       </dsp:txBody>
       <dsp:txXfrm>
-        <a:off x="3772329" y="459"/>
+        <a:off x="3779119" y="459"/>
         <a:ext cx="1293342" cy="548690"/>
       </dsp:txXfrm>
     </dsp:sp>
@@ -4574,7 +4578,7 @@
       </dsp:nvSpPr>
       <dsp:spPr>
         <a:xfrm>
-          <a:off x="921098" y="1179390"/>
+          <a:off x="914308" y="1179390"/>
           <a:ext cx="548690" cy="548690"/>
         </a:xfrm>
         <a:prstGeom prst="ellipse">
@@ -4614,7 +4618,7 @@
       </dsp:nvSpPr>
       <dsp:spPr>
         <a:xfrm>
-          <a:off x="1036323" y="1294615"/>
+          <a:off x="1029533" y="1294615"/>
           <a:ext cx="318240" cy="318240"/>
         </a:xfrm>
         <a:prstGeom prst="rect">
@@ -4671,7 +4675,7 @@
       </dsp:nvSpPr>
       <dsp:spPr>
         <a:xfrm>
-          <a:off x="1587365" y="1179390"/>
+          <a:off x="1580575" y="1179390"/>
           <a:ext cx="1293342" cy="548690"/>
         </a:xfrm>
         <a:prstGeom prst="rect">
@@ -4701,7 +4705,7 @@
         </a:bodyPr>
         <a:lstStyle/>
         <a:p>
-          <a:pPr marL="0" lvl="0" indent="0" algn="l" defTabSz="488950">
+          <a:pPr marL="0" lvl="0" indent="0" algn="l" defTabSz="800100">
             <a:lnSpc>
               <a:spcPct val="100000"/>
             </a:lnSpc>
@@ -4714,14 +4718,18 @@
             <a:buNone/>
           </a:pPr>
           <a:r>
-            <a:rPr lang="en-GB" sz="1100" kern="1200"/>
-            <a:t>Ultralytics - Framework</a:t>
+            <a:rPr lang="en-GB" sz="1800" kern="1200" dirty="0" err="1"/>
+            <a:t>Ultralytics</a:t>
           </a:r>
-          <a:endParaRPr lang="en-US" sz="1100" kern="1200"/>
+          <a:r>
+            <a:rPr lang="en-GB" sz="1800" kern="1200" dirty="0"/>
+            <a:t> - Framework</a:t>
+          </a:r>
+          <a:endParaRPr lang="en-US" sz="1800" kern="1200" dirty="0"/>
         </a:p>
       </dsp:txBody>
       <dsp:txXfrm>
-        <a:off x="1587365" y="1179390"/>
+        <a:off x="1580575" y="1179390"/>
         <a:ext cx="1293342" cy="548690"/>
       </dsp:txXfrm>
     </dsp:sp>
@@ -4732,7 +4740,7 @@
       </dsp:nvSpPr>
       <dsp:spPr>
         <a:xfrm>
-          <a:off x="3106062" y="1179390"/>
+          <a:off x="3099272" y="1179390"/>
           <a:ext cx="548690" cy="548690"/>
         </a:xfrm>
         <a:prstGeom prst="ellipse">
@@ -4772,7 +4780,7 @@
       </dsp:nvSpPr>
       <dsp:spPr>
         <a:xfrm>
-          <a:off x="3221287" y="1294615"/>
+          <a:off x="3214497" y="1294615"/>
           <a:ext cx="318240" cy="318240"/>
         </a:xfrm>
         <a:prstGeom prst="rect">
@@ -4829,7 +4837,7 @@
       </dsp:nvSpPr>
       <dsp:spPr>
         <a:xfrm>
-          <a:off x="3772329" y="1179390"/>
+          <a:off x="3765539" y="1179390"/>
           <a:ext cx="1293342" cy="548690"/>
         </a:xfrm>
         <a:prstGeom prst="rect">
@@ -4859,7 +4867,7 @@
         </a:bodyPr>
         <a:lstStyle/>
         <a:p>
-          <a:pPr marL="0" lvl="0" indent="0" algn="l" defTabSz="488950">
+          <a:pPr marL="0" lvl="0" indent="0" algn="l" defTabSz="800100">
             <a:lnSpc>
               <a:spcPct val="100000"/>
             </a:lnSpc>
@@ -4872,14 +4880,14 @@
             <a:buNone/>
           </a:pPr>
           <a:r>
-            <a:rPr lang="en-GB" sz="1100" kern="1200" dirty="0"/>
+            <a:rPr lang="en-GB" sz="1800" kern="1200" dirty="0"/>
             <a:t>OpenCV – Computer Vision Library</a:t>
           </a:r>
-          <a:endParaRPr lang="en-US" sz="1100" kern="1200" dirty="0"/>
+          <a:endParaRPr lang="en-US" sz="1800" kern="1200" dirty="0"/>
         </a:p>
       </dsp:txBody>
       <dsp:txXfrm>
-        <a:off x="3772329" y="1179390"/>
+        <a:off x="3765539" y="1179390"/>
         <a:ext cx="1293342" cy="548690"/>
       </dsp:txXfrm>
     </dsp:sp>
@@ -4890,7 +4898,7 @@
       </dsp:nvSpPr>
       <dsp:spPr>
         <a:xfrm>
-          <a:off x="921098" y="2358320"/>
+          <a:off x="914308" y="2358320"/>
           <a:ext cx="548690" cy="548690"/>
         </a:xfrm>
         <a:prstGeom prst="ellipse">
@@ -4930,7 +4938,7 @@
       </dsp:nvSpPr>
       <dsp:spPr>
         <a:xfrm>
-          <a:off x="1036323" y="2473545"/>
+          <a:off x="1029533" y="2473545"/>
           <a:ext cx="318240" cy="318240"/>
         </a:xfrm>
         <a:prstGeom prst="rect">
@@ -4987,7 +4995,7 @@
       </dsp:nvSpPr>
       <dsp:spPr>
         <a:xfrm>
-          <a:off x="1587365" y="2358320"/>
+          <a:off x="1580575" y="2358320"/>
           <a:ext cx="1293342" cy="548690"/>
         </a:xfrm>
         <a:prstGeom prst="rect">
@@ -5017,7 +5025,7 @@
         </a:bodyPr>
         <a:lstStyle/>
         <a:p>
-          <a:pPr marL="0" lvl="0" indent="0" algn="l" defTabSz="488950">
+          <a:pPr marL="0" lvl="0" indent="0" algn="l" defTabSz="800100">
             <a:lnSpc>
               <a:spcPct val="100000"/>
             </a:lnSpc>
@@ -5030,14 +5038,14 @@
             <a:buNone/>
           </a:pPr>
           <a:r>
-            <a:rPr lang="en-GB" sz="1100" kern="1200"/>
+            <a:rPr lang="en-GB" sz="1800" kern="1200" dirty="0"/>
             <a:t>Flask – Web Framework</a:t>
           </a:r>
-          <a:endParaRPr lang="en-US" sz="1100" kern="1200"/>
+          <a:endParaRPr lang="en-US" sz="1800" kern="1200" dirty="0"/>
         </a:p>
       </dsp:txBody>
       <dsp:txXfrm>
-        <a:off x="1587365" y="2358320"/>
+        <a:off x="1580575" y="2358320"/>
         <a:ext cx="1293342" cy="548690"/>
       </dsp:txXfrm>
     </dsp:sp>
@@ -5048,7 +5056,7 @@
       </dsp:nvSpPr>
       <dsp:spPr>
         <a:xfrm>
-          <a:off x="3106062" y="2358320"/>
+          <a:off x="3099272" y="2358320"/>
           <a:ext cx="548690" cy="548690"/>
         </a:xfrm>
         <a:prstGeom prst="ellipse">
@@ -5088,7 +5096,7 @@
       </dsp:nvSpPr>
       <dsp:spPr>
         <a:xfrm>
-          <a:off x="3221287" y="2473545"/>
+          <a:off x="3214497" y="2473545"/>
           <a:ext cx="318240" cy="318240"/>
         </a:xfrm>
         <a:prstGeom prst="rect">
@@ -5145,7 +5153,7 @@
       </dsp:nvSpPr>
       <dsp:spPr>
         <a:xfrm>
-          <a:off x="3772329" y="2358320"/>
+          <a:off x="3765539" y="2358320"/>
           <a:ext cx="1293342" cy="548690"/>
         </a:xfrm>
         <a:prstGeom prst="rect">
@@ -5175,7 +5183,7 @@
         </a:bodyPr>
         <a:lstStyle/>
         <a:p>
-          <a:pPr marL="0" lvl="0" indent="0" algn="l" defTabSz="488950">
+          <a:pPr marL="0" lvl="0" indent="0" algn="l" defTabSz="800100">
             <a:lnSpc>
               <a:spcPct val="100000"/>
             </a:lnSpc>
@@ -5188,14 +5196,14 @@
             <a:buNone/>
           </a:pPr>
           <a:r>
-            <a:rPr lang="en-GB" sz="1100" kern="1200"/>
+            <a:rPr lang="en-GB" sz="1800" kern="1200" dirty="0"/>
             <a:t>React – Front End</a:t>
           </a:r>
-          <a:endParaRPr lang="en-US" sz="1100" kern="1200"/>
+          <a:endParaRPr lang="en-US" sz="1800" kern="1200" dirty="0"/>
         </a:p>
       </dsp:txBody>
       <dsp:txXfrm>
-        <a:off x="3772329" y="2358320"/>
+        <a:off x="3765539" y="2358320"/>
         <a:ext cx="1293342" cy="548690"/>
       </dsp:txXfrm>
     </dsp:sp>
@@ -5206,7 +5214,7 @@
       </dsp:nvSpPr>
       <dsp:spPr>
         <a:xfrm>
-          <a:off x="921098" y="3537250"/>
+          <a:off x="914308" y="3537250"/>
           <a:ext cx="548690" cy="548690"/>
         </a:xfrm>
         <a:prstGeom prst="ellipse">
@@ -5246,7 +5254,7 @@
       </dsp:nvSpPr>
       <dsp:spPr>
         <a:xfrm>
-          <a:off x="1036323" y="3652475"/>
+          <a:off x="1029533" y="3652475"/>
           <a:ext cx="318240" cy="318240"/>
         </a:xfrm>
         <a:prstGeom prst="rect">
@@ -5303,7 +5311,7 @@
       </dsp:nvSpPr>
       <dsp:spPr>
         <a:xfrm>
-          <a:off x="1587365" y="3537250"/>
+          <a:off x="1580575" y="3537250"/>
           <a:ext cx="1293342" cy="548690"/>
         </a:xfrm>
         <a:prstGeom prst="rect">
@@ -5333,7 +5341,7 @@
         </a:bodyPr>
         <a:lstStyle/>
         <a:p>
-          <a:pPr marL="0" lvl="0" indent="0" algn="l" defTabSz="488950">
+          <a:pPr marL="0" lvl="0" indent="0" algn="l" defTabSz="800100">
             <a:lnSpc>
               <a:spcPct val="100000"/>
             </a:lnSpc>
@@ -5346,14 +5354,14 @@
             <a:buNone/>
           </a:pPr>
           <a:r>
-            <a:rPr lang="en-GB" sz="1100" kern="1200"/>
+            <a:rPr lang="en-GB" sz="1800" kern="1200" dirty="0"/>
             <a:t>SMTP – Email Service</a:t>
           </a:r>
-          <a:endParaRPr lang="en-US" sz="1100" kern="1200"/>
+          <a:endParaRPr lang="en-US" sz="1800" kern="1200" dirty="0"/>
         </a:p>
       </dsp:txBody>
       <dsp:txXfrm>
-        <a:off x="1587365" y="3537250"/>
+        <a:off x="1580575" y="3537250"/>
         <a:ext cx="1293342" cy="548690"/>
       </dsp:txXfrm>
     </dsp:sp>
@@ -5364,7 +5372,7 @@
       </dsp:nvSpPr>
       <dsp:spPr>
         <a:xfrm>
-          <a:off x="3106062" y="3537250"/>
+          <a:off x="3099272" y="3537250"/>
           <a:ext cx="548690" cy="548690"/>
         </a:xfrm>
         <a:prstGeom prst="ellipse">
@@ -5404,7 +5412,7 @@
       </dsp:nvSpPr>
       <dsp:spPr>
         <a:xfrm>
-          <a:off x="3221287" y="3652475"/>
+          <a:off x="3214497" y="3652475"/>
           <a:ext cx="318240" cy="318240"/>
         </a:xfrm>
         <a:prstGeom prst="rect">
@@ -5461,7 +5469,7 @@
       </dsp:nvSpPr>
       <dsp:spPr>
         <a:xfrm>
-          <a:off x="3772329" y="3537250"/>
+          <a:off x="3765539" y="3537250"/>
           <a:ext cx="1293342" cy="548690"/>
         </a:xfrm>
         <a:prstGeom prst="rect">
@@ -5491,7 +5499,7 @@
         </a:bodyPr>
         <a:lstStyle/>
         <a:p>
-          <a:pPr marL="0" lvl="0" indent="0" algn="l" defTabSz="488950">
+          <a:pPr marL="0" lvl="0" indent="0" algn="l" defTabSz="800100">
             <a:lnSpc>
               <a:spcPct val="100000"/>
             </a:lnSpc>
@@ -5504,14 +5512,14 @@
             <a:buNone/>
           </a:pPr>
           <a:r>
-            <a:rPr lang="en-GB" sz="1100" kern="1200"/>
+            <a:rPr lang="en-GB" sz="1800" kern="1200" dirty="0"/>
             <a:t>MySQL - Database</a:t>
           </a:r>
-          <a:endParaRPr lang="en-US" sz="1100" kern="1200"/>
+          <a:endParaRPr lang="en-US" sz="1800" kern="1200" dirty="0"/>
         </a:p>
       </dsp:txBody>
       <dsp:txXfrm>
-        <a:off x="3772329" y="3537250"/>
+        <a:off x="3765539" y="3537250"/>
         <a:ext cx="1293342" cy="548690"/>
       </dsp:txXfrm>
     </dsp:sp>
@@ -11184,7 +11192,7 @@
           <a:p>
             <a:fld id="{74FCF980-36E5-46BF-A02A-756B7FE0A693}" type="datetimeFigureOut">
               <a:rPr lang="en-GB" smtClean="0"/>
-              <a:t>30/11/2024</a:t>
+              <a:t>04/12/2024</a:t>
             </a:fld>
             <a:endParaRPr lang="en-GB"/>
           </a:p>
@@ -11601,7 +11609,7 @@
           <a:p>
             <a:fld id="{7E55B3EA-B30C-4CE3-B538-BC7F603EE92A}" type="datetime1">
               <a:rPr lang="en-GB" smtClean="0"/>
-              <a:t>30/11/2024</a:t>
+              <a:t>04/12/2024</a:t>
             </a:fld>
             <a:endParaRPr lang="en-GB"/>
           </a:p>
@@ -11801,7 +11809,7 @@
           <a:p>
             <a:fld id="{908DF4FF-43EB-43ED-BF8E-EF1421EE1B33}" type="datetime1">
               <a:rPr lang="en-GB" smtClean="0"/>
-              <a:t>30/11/2024</a:t>
+              <a:t>04/12/2024</a:t>
             </a:fld>
             <a:endParaRPr lang="en-GB"/>
           </a:p>
@@ -12011,7 +12019,7 @@
           <a:p>
             <a:fld id="{F5FB5ABF-7BF5-4383-BD15-C04E1EF89981}" type="datetime1">
               <a:rPr lang="en-GB" smtClean="0"/>
-              <a:t>30/11/2024</a:t>
+              <a:t>04/12/2024</a:t>
             </a:fld>
             <a:endParaRPr lang="en-GB"/>
           </a:p>
@@ -12211,7 +12219,7 @@
           <a:p>
             <a:fld id="{3249EB88-2E63-470B-B5AE-ED8F04DEB571}" type="datetime1">
               <a:rPr lang="en-GB" smtClean="0"/>
-              <a:t>30/11/2024</a:t>
+              <a:t>04/12/2024</a:t>
             </a:fld>
             <a:endParaRPr lang="en-GB" dirty="0"/>
           </a:p>
@@ -12508,7 +12516,7 @@
           <a:p>
             <a:fld id="{8A25558C-F5C9-425F-A937-DAD336474D19}" type="datetime1">
               <a:rPr lang="en-GB" smtClean="0"/>
-              <a:t>30/11/2024</a:t>
+              <a:t>04/12/2024</a:t>
             </a:fld>
             <a:endParaRPr lang="en-GB"/>
           </a:p>
@@ -12776,7 +12784,7 @@
           <a:p>
             <a:fld id="{78F23361-B348-4CBC-9D98-FFEC573232E9}" type="datetime1">
               <a:rPr lang="en-GB" smtClean="0"/>
-              <a:t>30/11/2024</a:t>
+              <a:t>04/12/2024</a:t>
             </a:fld>
             <a:endParaRPr lang="en-GB"/>
           </a:p>
@@ -13191,7 +13199,7 @@
           <a:p>
             <a:fld id="{209E1356-F7A0-4DDA-9B79-8677F0203A36}" type="datetime1">
               <a:rPr lang="en-GB" smtClean="0"/>
-              <a:t>30/11/2024</a:t>
+              <a:t>04/12/2024</a:t>
             </a:fld>
             <a:endParaRPr lang="en-GB"/>
           </a:p>
@@ -13333,7 +13341,7 @@
           <a:p>
             <a:fld id="{7B0BD8A4-DB30-4644-BD53-95B03F580EBF}" type="datetime1">
               <a:rPr lang="en-GB" smtClean="0"/>
-              <a:t>30/11/2024</a:t>
+              <a:t>04/12/2024</a:t>
             </a:fld>
             <a:endParaRPr lang="en-GB"/>
           </a:p>
@@ -13446,7 +13454,7 @@
           <a:p>
             <a:fld id="{EBE70D1A-1D8E-4DCC-9397-026B2065BFC1}" type="datetime1">
               <a:rPr lang="en-GB" smtClean="0"/>
-              <a:t>30/11/2024</a:t>
+              <a:t>04/12/2024</a:t>
             </a:fld>
             <a:endParaRPr lang="en-GB"/>
           </a:p>
@@ -13759,7 +13767,7 @@
           <a:p>
             <a:fld id="{1D27C71C-4D63-45B1-B210-A6E88395339E}" type="datetime1">
               <a:rPr lang="en-GB" smtClean="0"/>
-              <a:t>30/11/2024</a:t>
+              <a:t>04/12/2024</a:t>
             </a:fld>
             <a:endParaRPr lang="en-GB"/>
           </a:p>
@@ -14048,7 +14056,7 @@
           <a:p>
             <a:fld id="{CE4A0315-D938-4806-831E-5BEF87E79DEC}" type="datetime1">
               <a:rPr lang="en-GB" smtClean="0"/>
-              <a:t>30/11/2024</a:t>
+              <a:t>04/12/2024</a:t>
             </a:fld>
             <a:endParaRPr lang="en-GB"/>
           </a:p>
@@ -14291,7 +14299,7 @@
           <a:p>
             <a:fld id="{EDF9EF3A-9B5C-4F8E-BE21-1A9759F13C31}" type="datetime1">
               <a:rPr lang="en-GB" smtClean="0"/>
-              <a:t>30/11/2024</a:t>
+              <a:t>04/12/2024</a:t>
             </a:fld>
             <a:endParaRPr lang="en-GB"/>
           </a:p>
@@ -25901,7 +25909,7 @@
             <p:ph sz="half" idx="1"/>
             <p:extLst>
               <p:ext uri="{D42A27DB-BD31-4B8C-83A1-F6EECF244321}">
-                <p14:modId xmlns:p14="http://schemas.microsoft.com/office/powerpoint/2010/main" val="805853074"/>
+                <p14:modId xmlns:p14="http://schemas.microsoft.com/office/powerpoint/2010/main" val="317243692"/>
               </p:ext>
             </p:extLst>
           </p:nvPr>

</xml_diff>